<commit_message>
fixed page num detection, page num order check, added heading font color check, false both marking check.
</commit_message>
<xml_diff>
--- a/data/testTemplate1.pptx
+++ b/data/testTemplate1.pptx
@@ -5,13 +5,15 @@
     <p:sldMasterId id="2147483648" r:id="rId1"/>
   </p:sldMasterIdLst>
   <p:notesMasterIdLst>
-    <p:notesMasterId r:id="rId6"/>
+    <p:notesMasterId r:id="rId8"/>
   </p:notesMasterIdLst>
   <p:sldIdLst>
     <p:sldId id="256" r:id="rId2"/>
     <p:sldId id="257" r:id="rId3"/>
     <p:sldId id="258" r:id="rId4"/>
     <p:sldId id="259" r:id="rId5"/>
+    <p:sldId id="260" r:id="rId6"/>
+    <p:sldId id="261" r:id="rId7"/>
   </p:sldIdLst>
   <p:sldSz cx="12192000" cy="6858000"/>
   <p:notesSz cx="6858000" cy="9144000"/>
@@ -200,7 +202,7 @@
           <a:p>
             <a:fld id="{6753CBDD-ACC6-4202-B019-53FB3C75EDCD}" type="datetimeFigureOut">
               <a:rPr lang="en-US" smtClean="0"/>
-              <a:t>7/14/2026</a:t>
+              <a:t>7/15/2026</a:t>
             </a:fld>
             <a:endParaRPr lang="en-US"/>
           </a:p>
@@ -614,7 +616,7 @@
           <a:p>
             <a:fld id="{304DA26E-80B4-4B8C-B4DA-06AE1A3086F5}" type="datetime1">
               <a:rPr lang="en-US" smtClean="0"/>
-              <a:t>7/14/2026</a:t>
+              <a:t>7/15/2026</a:t>
             </a:fld>
             <a:endParaRPr lang="en-US"/>
           </a:p>
@@ -815,7 +817,7 @@
           <a:p>
             <a:fld id="{C90A7920-1FA9-4DE4-AA75-DA63C82CD230}" type="datetime1">
               <a:rPr lang="en-US" smtClean="0"/>
-              <a:t>7/14/2026</a:t>
+              <a:t>7/15/2026</a:t>
             </a:fld>
             <a:endParaRPr lang="en-US"/>
           </a:p>
@@ -1026,7 +1028,7 @@
           <a:p>
             <a:fld id="{2A3D9C00-5769-46D3-AAAF-5DBDA40E7049}" type="datetime1">
               <a:rPr lang="en-US" smtClean="0"/>
-              <a:t>7/14/2026</a:t>
+              <a:t>7/15/2026</a:t>
             </a:fld>
             <a:endParaRPr lang="en-US"/>
           </a:p>
@@ -1227,7 +1229,7 @@
           <a:p>
             <a:fld id="{E94D0B35-602C-4814-B63D-6284F42350B2}" type="datetime1">
               <a:rPr lang="en-US" smtClean="0"/>
-              <a:t>7/14/2026</a:t>
+              <a:t>7/15/2026</a:t>
             </a:fld>
             <a:endParaRPr lang="en-US"/>
           </a:p>
@@ -1505,7 +1507,7 @@
           <a:p>
             <a:fld id="{61980A6E-0686-44B4-8140-6458080FAFFB}" type="datetime1">
               <a:rPr lang="en-US" smtClean="0"/>
-              <a:t>7/14/2026</a:t>
+              <a:t>7/15/2026</a:t>
             </a:fld>
             <a:endParaRPr lang="en-US"/>
           </a:p>
@@ -1773,7 +1775,7 @@
           <a:p>
             <a:fld id="{BD92B0FD-08D6-4DBA-9606-AE961961A423}" type="datetime1">
               <a:rPr lang="en-US" smtClean="0"/>
-              <a:t>7/14/2026</a:t>
+              <a:t>7/15/2026</a:t>
             </a:fld>
             <a:endParaRPr lang="en-US"/>
           </a:p>
@@ -2188,7 +2190,7 @@
           <a:p>
             <a:fld id="{539C40DC-A217-4847-8520-69E01AF22AC2}" type="datetime1">
               <a:rPr lang="en-US" smtClean="0"/>
-              <a:t>7/14/2026</a:t>
+              <a:t>7/15/2026</a:t>
             </a:fld>
             <a:endParaRPr lang="en-US"/>
           </a:p>
@@ -2332,7 +2334,7 @@
           <a:p>
             <a:fld id="{812CE312-4BB8-4E90-AB22-528B0CFCBD3F}" type="datetime1">
               <a:rPr lang="en-US" smtClean="0"/>
-              <a:t>7/14/2026</a:t>
+              <a:t>7/15/2026</a:t>
             </a:fld>
             <a:endParaRPr lang="en-US"/>
           </a:p>
@@ -2448,7 +2450,7 @@
           <a:p>
             <a:fld id="{1BC62EC3-9AEE-4356-9A04-DB80F70D6179}" type="datetime1">
               <a:rPr lang="en-US" smtClean="0"/>
-              <a:t>7/14/2026</a:t>
+              <a:t>7/15/2026</a:t>
             </a:fld>
             <a:endParaRPr lang="en-US"/>
           </a:p>
@@ -2762,7 +2764,7 @@
           <a:p>
             <a:fld id="{C1E966EE-4EAE-4BF7-971D-73D53350C6E8}" type="datetime1">
               <a:rPr lang="en-US" smtClean="0"/>
-              <a:t>7/14/2026</a:t>
+              <a:t>7/15/2026</a:t>
             </a:fld>
             <a:endParaRPr lang="en-US"/>
           </a:p>
@@ -3053,7 +3055,7 @@
           <a:p>
             <a:fld id="{110D9623-39FD-4534-AC27-23F2791DEF67}" type="datetime1">
               <a:rPr lang="en-US" smtClean="0"/>
-              <a:t>7/14/2026</a:t>
+              <a:t>7/15/2026</a:t>
             </a:fld>
             <a:endParaRPr lang="en-US"/>
           </a:p>
@@ -3297,7 +3299,7 @@
           <a:p>
             <a:fld id="{D476097E-2606-41EA-AFAD-F9B14B39BC5E}" type="datetime1">
               <a:rPr lang="en-US" smtClean="0"/>
-              <a:t>7/14/2026</a:t>
+              <a:t>7/15/2026</a:t>
             </a:fld>
             <a:endParaRPr lang="en-US"/>
           </a:p>
@@ -4376,6 +4378,268 @@
     <p:extLst>
       <p:ext uri="{BB962C8B-B14F-4D97-AF65-F5344CB8AC3E}">
         <p14:creationId xmlns:p14="http://schemas.microsoft.com/office/powerpoint/2010/main" val="3496586311"/>
+      </p:ext>
+    </p:extLst>
+  </p:cSld>
+  <p:clrMapOvr>
+    <a:masterClrMapping/>
+  </p:clrMapOvr>
+</p:sld>
+</file>
+
+<file path=ppt/slides/slide5.xml><?xml version="1.0" encoding="utf-8"?>
+<p:sld xmlns:a="http://schemas.openxmlformats.org/drawingml/2006/main" xmlns:r="http://schemas.openxmlformats.org/officeDocument/2006/relationships" xmlns:p="http://schemas.openxmlformats.org/presentationml/2006/main">
+  <p:cSld>
+    <p:spTree>
+      <p:nvGrpSpPr>
+        <p:cNvPr id="1" name=""/>
+        <p:cNvGrpSpPr/>
+        <p:nvPr/>
+      </p:nvGrpSpPr>
+      <p:grpSpPr>
+        <a:xfrm>
+          <a:off x="0" y="0"/>
+          <a:ext cx="0" cy="0"/>
+          <a:chOff x="0" y="0"/>
+          <a:chExt cx="0" cy="0"/>
+        </a:xfrm>
+      </p:grpSpPr>
+      <p:sp>
+        <p:nvSpPr>
+          <p:cNvPr id="2" name="Title 1">
+            <a:extLst>
+              <a:ext uri="{FF2B5EF4-FFF2-40B4-BE49-F238E27FC236}">
+                <a16:creationId xmlns:a16="http://schemas.microsoft.com/office/drawing/2014/main" id="{2EFE1C9C-80E6-4467-562F-B073F9F84C28}"/>
+              </a:ext>
+            </a:extLst>
+          </p:cNvPr>
+          <p:cNvSpPr>
+            <a:spLocks noGrp="1"/>
+          </p:cNvSpPr>
+          <p:nvPr>
+            <p:ph type="title"/>
+          </p:nvPr>
+        </p:nvSpPr>
+        <p:spPr/>
+        <p:txBody>
+          <a:bodyPr>
+            <a:noAutofit/>
+          </a:bodyPr>
+          <a:lstStyle/>
+          <a:p>
+            <a:r>
+              <a:rPr lang="en-US" sz="2800" dirty="0">
+                <a:latin typeface="Algerian" panose="04020705040A02060702" pitchFamily="82" charset="0"/>
+              </a:rPr>
+              <a:t>Page Num and heading test</a:t>
+            </a:r>
+          </a:p>
+        </p:txBody>
+      </p:sp>
+      <p:sp>
+        <p:nvSpPr>
+          <p:cNvPr id="3" name="Content Placeholder 2">
+            <a:extLst>
+              <a:ext uri="{FF2B5EF4-FFF2-40B4-BE49-F238E27FC236}">
+                <a16:creationId xmlns:a16="http://schemas.microsoft.com/office/drawing/2014/main" id="{0EFCA6A3-B928-D508-D976-2ECC16A471B3}"/>
+              </a:ext>
+            </a:extLst>
+          </p:cNvPr>
+          <p:cNvSpPr>
+            <a:spLocks noGrp="1"/>
+          </p:cNvSpPr>
+          <p:nvPr>
+            <p:ph idx="1"/>
+          </p:nvPr>
+        </p:nvSpPr>
+        <p:spPr/>
+        <p:txBody>
+          <a:bodyPr/>
+          <a:lstStyle/>
+          <a:p>
+            <a:endParaRPr lang="en-US"/>
+          </a:p>
+        </p:txBody>
+      </p:sp>
+      <p:sp>
+        <p:nvSpPr>
+          <p:cNvPr id="5" name="Slide Number Placeholder 4">
+            <a:extLst>
+              <a:ext uri="{FF2B5EF4-FFF2-40B4-BE49-F238E27FC236}">
+                <a16:creationId xmlns:a16="http://schemas.microsoft.com/office/drawing/2014/main" id="{B07E816C-35DF-313E-6FA8-80778DF9B9F3}"/>
+              </a:ext>
+            </a:extLst>
+          </p:cNvPr>
+          <p:cNvSpPr>
+            <a:spLocks noGrp="1"/>
+          </p:cNvSpPr>
+          <p:nvPr>
+            <p:ph type="sldNum" sz="quarter" idx="12"/>
+          </p:nvPr>
+        </p:nvSpPr>
+        <p:spPr/>
+        <p:txBody>
+          <a:bodyPr/>
+          <a:lstStyle/>
+          <a:p>
+            <a:fld id="{B8122114-3C96-4A07-A75A-F7B0C0D9400A}" type="slidenum">
+              <a:rPr lang="en-US" smtClean="0"/>
+              <a:t>5</a:t>
+            </a:fld>
+            <a:r>
+              <a:rPr lang="en-US" dirty="0"/>
+              <a:t>5</a:t>
+            </a:r>
+          </a:p>
+        </p:txBody>
+      </p:sp>
+    </p:spTree>
+    <p:extLst>
+      <p:ext uri="{BB962C8B-B14F-4D97-AF65-F5344CB8AC3E}">
+        <p14:creationId xmlns:p14="http://schemas.microsoft.com/office/powerpoint/2010/main" val="1789513275"/>
+      </p:ext>
+    </p:extLst>
+  </p:cSld>
+  <p:clrMapOvr>
+    <a:masterClrMapping/>
+  </p:clrMapOvr>
+</p:sld>
+</file>
+
+<file path=ppt/slides/slide6.xml><?xml version="1.0" encoding="utf-8"?>
+<p:sld xmlns:a="http://schemas.openxmlformats.org/drawingml/2006/main" xmlns:r="http://schemas.openxmlformats.org/officeDocument/2006/relationships" xmlns:p="http://schemas.openxmlformats.org/presentationml/2006/main">
+  <p:cSld>
+    <p:spTree>
+      <p:nvGrpSpPr>
+        <p:cNvPr id="1" name=""/>
+        <p:cNvGrpSpPr/>
+        <p:nvPr/>
+      </p:nvGrpSpPr>
+      <p:grpSpPr>
+        <a:xfrm>
+          <a:off x="0" y="0"/>
+          <a:ext cx="0" cy="0"/>
+          <a:chOff x="0" y="0"/>
+          <a:chExt cx="0" cy="0"/>
+        </a:xfrm>
+      </p:grpSpPr>
+      <p:sp>
+        <p:nvSpPr>
+          <p:cNvPr id="2" name="Title 1">
+            <a:extLst>
+              <a:ext uri="{FF2B5EF4-FFF2-40B4-BE49-F238E27FC236}">
+                <a16:creationId xmlns:a16="http://schemas.microsoft.com/office/drawing/2014/main" id="{2D17191E-93CB-06F6-4B70-08FFAE4A5E76}"/>
+              </a:ext>
+            </a:extLst>
+          </p:cNvPr>
+          <p:cNvSpPr>
+            <a:spLocks noGrp="1"/>
+          </p:cNvSpPr>
+          <p:nvPr>
+            <p:ph type="title"/>
+          </p:nvPr>
+        </p:nvSpPr>
+        <p:spPr/>
+        <p:txBody>
+          <a:bodyPr/>
+          <a:lstStyle/>
+          <a:p>
+            <a:r>
+              <a:rPr lang="en-US" dirty="0">
+                <a:solidFill>
+                  <a:srgbClr val="FF0000"/>
+                </a:solidFill>
+              </a:rPr>
+              <a:t>Page num Test</a:t>
+            </a:r>
+          </a:p>
+        </p:txBody>
+      </p:sp>
+      <p:sp>
+        <p:nvSpPr>
+          <p:cNvPr id="3" name="Content Placeholder 2">
+            <a:extLst>
+              <a:ext uri="{FF2B5EF4-FFF2-40B4-BE49-F238E27FC236}">
+                <a16:creationId xmlns:a16="http://schemas.microsoft.com/office/drawing/2014/main" id="{342B3CBA-45C8-26FB-0492-F054F64069E3}"/>
+              </a:ext>
+            </a:extLst>
+          </p:cNvPr>
+          <p:cNvSpPr>
+            <a:spLocks noGrp="1"/>
+          </p:cNvSpPr>
+          <p:nvPr>
+            <p:ph idx="1"/>
+          </p:nvPr>
+        </p:nvSpPr>
+        <p:spPr/>
+        <p:txBody>
+          <a:bodyPr/>
+          <a:lstStyle/>
+          <a:p>
+            <a:endParaRPr lang="en-US" dirty="0"/>
+          </a:p>
+        </p:txBody>
+      </p:sp>
+      <p:sp>
+        <p:nvSpPr>
+          <p:cNvPr id="4" name="Footer Placeholder 3">
+            <a:extLst>
+              <a:ext uri="{FF2B5EF4-FFF2-40B4-BE49-F238E27FC236}">
+                <a16:creationId xmlns:a16="http://schemas.microsoft.com/office/drawing/2014/main" id="{BEA7A6CB-4AEB-DD62-6895-A037E0332529}"/>
+              </a:ext>
+            </a:extLst>
+          </p:cNvPr>
+          <p:cNvSpPr>
+            <a:spLocks noGrp="1"/>
+          </p:cNvSpPr>
+          <p:nvPr>
+            <p:ph type="ftr" sz="quarter" idx="11"/>
+          </p:nvPr>
+        </p:nvSpPr>
+        <p:spPr/>
+        <p:txBody>
+          <a:bodyPr/>
+          <a:lstStyle/>
+          <a:p>
+            <a:r>
+              <a:rPr lang="en-US"/>
+              <a:t>Reviewed and determined not to contain CUI</a:t>
+            </a:r>
+          </a:p>
+        </p:txBody>
+      </p:sp>
+      <p:sp>
+        <p:nvSpPr>
+          <p:cNvPr id="5" name="Slide Number Placeholder 4">
+            <a:extLst>
+              <a:ext uri="{FF2B5EF4-FFF2-40B4-BE49-F238E27FC236}">
+                <a16:creationId xmlns:a16="http://schemas.microsoft.com/office/drawing/2014/main" id="{86841764-CB7F-D469-EC85-E1AAEE8B9124}"/>
+              </a:ext>
+            </a:extLst>
+          </p:cNvPr>
+          <p:cNvSpPr>
+            <a:spLocks noGrp="1"/>
+          </p:cNvSpPr>
+          <p:nvPr>
+            <p:ph type="sldNum" sz="quarter" idx="12"/>
+          </p:nvPr>
+        </p:nvSpPr>
+        <p:spPr/>
+        <p:txBody>
+          <a:bodyPr/>
+          <a:lstStyle/>
+          <a:p>
+            <a:r>
+              <a:rPr lang="en-US" dirty="0"/>
+              <a:t>#</a:t>
+            </a:r>
+          </a:p>
+        </p:txBody>
+      </p:sp>
+    </p:spTree>
+    <p:extLst>
+      <p:ext uri="{BB962C8B-B14F-4D97-AF65-F5344CB8AC3E}">
+        <p14:creationId xmlns:p14="http://schemas.microsoft.com/office/powerpoint/2010/main" val="3081164646"/>
       </p:ext>
     </p:extLst>
   </p:cSld>

</xml_diff>